<commit_message>
Level 5 Lesson 13 draft listening audio (1:47)
</commit_message>
<xml_diff>
--- a/level5/slides/Level5_Lesson13_Slides.pptx
+++ b/level5/slides/Level5_Lesson13_Slides.pptx
@@ -8,32 +8,32 @@
     <p:notesMasterId r:id="rId22"/>
   </p:notesMasterIdLst>
   <p:sldIdLst>
-    <p:sldId id="939" r:id="rId33"/>
-    <p:sldId id="940" r:id="rId34"/>
-    <p:sldId id="941" r:id="rId35"/>
-    <p:sldId id="942" r:id="rId36"/>
-    <p:sldId id="943" r:id="rId31"/>
-    <p:sldId id="944" r:id="rId30"/>
-    <p:sldId id="945" r:id="rId29"/>
-    <p:sldId id="946" r:id="rId28"/>
-    <p:sldId id="947" r:id="rId27"/>
-    <p:sldId id="948" r:id="rId20"/>
-    <p:sldId id="949" r:id="rId18"/>
-    <p:sldId id="950" r:id="rId17"/>
-    <p:sldId id="951" r:id="rId16"/>
-    <p:sldId id="952" r:id="rId14"/>
-    <p:sldId id="953" r:id="rId13"/>
-    <p:sldId id="954" r:id="rId12"/>
-    <p:sldId id="955" r:id="rId11"/>
-    <p:sldId id="956" r:id="rId10"/>
-    <p:sldId id="957" r:id="rId8"/>
-    <p:sldId id="958" r:id="rId7"/>
-    <p:sldId id="959" r:id="rId6"/>
-    <p:sldId id="960" r:id="rId5"/>
-    <p:sldId id="961" r:id="rId4"/>
-    <p:sldId id="962" r:id="rId3"/>
-    <p:sldId id="963" r:id="rId57"/>
-    <p:sldId id="964" r:id="rId2"/>
+    <p:sldId id="1121" r:id="rId32"/>
+    <p:sldId id="1122" r:id="rId21"/>
+    <p:sldId id="1123" r:id="rId19"/>
+    <p:sldId id="1124" r:id="rId15"/>
+    <p:sldId id="1125" r:id="rId37"/>
+    <p:sldId id="1126" r:id="rId38"/>
+    <p:sldId id="1127" r:id="rId39"/>
+    <p:sldId id="1128" r:id="rId40"/>
+    <p:sldId id="1129" r:id="rId41"/>
+    <p:sldId id="1130" r:id="rId42"/>
+    <p:sldId id="1131" r:id="rId43"/>
+    <p:sldId id="1132" r:id="rId44"/>
+    <p:sldId id="1133" r:id="rId45"/>
+    <p:sldId id="1134" r:id="rId46"/>
+    <p:sldId id="1135" r:id="rId47"/>
+    <p:sldId id="1136" r:id="rId48"/>
+    <p:sldId id="1137" r:id="rId49"/>
+    <p:sldId id="1138" r:id="rId50"/>
+    <p:sldId id="1139" r:id="rId51"/>
+    <p:sldId id="1140" r:id="rId52"/>
+    <p:sldId id="1141" r:id="rId53"/>
+    <p:sldId id="1142" r:id="rId54"/>
+    <p:sldId id="1143" r:id="rId55"/>
+    <p:sldId id="1144" r:id="rId56"/>
+    <p:sldId id="1145" r:id="rId9"/>
+    <p:sldId id="1146" r:id="rId58"/>
   </p:sldIdLst>
   <p:sldSz cx="12192000" cy="6858000"/>
   <p:notesSz cx="6858000" cy="12192000"/>
@@ -481,7 +481,7 @@
 </p:notesMaster>
 </file>
 
-<file path=ppt/notesSlides/notesSlide1.xml><?xml version="1.0" encoding="utf-8"?>
+<file path=ppt/notesSlides/notesSlide14.xml><?xml version="1.0" encoding="utf-8"?>
 <p:notes xmlns:a="http://schemas.openxmlformats.org/drawingml/2006/main" xmlns:p="http://schemas.openxmlformats.org/presentationml/2006/main" xmlns:r="http://schemas.openxmlformats.org/officeDocument/2006/relationships">
   <p:cSld>
     <p:spTree>
@@ -526,27 +526,17 @@
           <a:lstStyle/>
           <a:p>
             <a:r>
-              <a:t>Credits. You don't need to read this slide in class.</a:t>
-            </a:r>
-          </a:p>
-          <a:p>
-            <a:r>
-              <a:t>Pictures: Twemoji graphics by Twitter, Inc. and other contributors, CC BY 4.0; the file-by-file list is in images/CREDITS.md.</a:t>
-            </a:r>
-          </a:p>
-          <a:p>
-            <a:r>
-              <a:t>Audio: the listening audio for this lesson (about 2:20) is coming soon. It will use computer-generated voices (Chatterbox TTS cloned from synthetic Kokoro-82M reference clips); no recordings of real people. Until it is ready, read the listening script (in the notes of the Before You Listen slide) with a volunteer. The names and the story are invented.</a:t>
-            </a:r>
-          </a:p>
-          <a:p>
-            <a:r>
-              <a:t>Course materials: © 2026 the authors, licensed under CC BY-NC-SA 4.0 (https://creativecommons.org/licenses/by-nc-sa/4.0/).</a:t>
-            </a:r>
-          </a:p>
-          <a:p>
-            <a:r>
-              <a:t>Lesson plan: Picture Credits. Picture list: images/CREDITS.md.</a:t>
+              <a:t>Each click shows the next card.</a:t>
+            </a:r>
+          </a:p>
+          <a:p>
+            <a:r>
+              <a:t>A asks. B answers. Then switch.</a:t>
+            </a:r>
+          </a:p>
+          <a:p>
+            <a:r>
+              <a:t>Lesson plan: Step 1; Opening Talk page.</a:t>
             </a:r>
           </a:p>
         </p:txBody>
@@ -571,7 +561,7 @@
 </p:notes>
 </file>
 
-<file path=ppt/notesSlides/notesSlide10.xml><?xml version="1.0" encoding="utf-8"?>
+<file path=ppt/notesSlides/notesSlide18.xml><?xml version="1.0" encoding="utf-8"?>
 <p:notes xmlns:a="http://schemas.openxmlformats.org/drawingml/2006/main" xmlns:p="http://schemas.openxmlformats.org/presentationml/2006/main" xmlns:r="http://schemas.openxmlformats.org/officeDocument/2006/relationships">
   <p:cSld>
     <p:spTree>
@@ -616,12 +606,22 @@
           <a:lstStyle/>
           <a:p>
             <a:r>
-              <a:t>Click to show each answer: 1 Introduction • 2 Example • 3 Example • 4 Conclusion • 5 Conclusion • 6 Example</a:t>
-            </a:r>
-          </a:p>
-          <a:p>
-            <a:r>
-              <a:t>Lesson plan: Step 4; Grammar Practice A; Answer key.</a:t>
+              <a:t>Step 1 · 6:00–6:06 · Opening Talk.</a:t>
+            </a:r>
+          </a:p>
+          <a:p>
+            <a:r>
+              <a:t>Work with a partner.</a:t>
+            </a:r>
+          </a:p>
+          <a:p>
+            <a:r>
+              <a:t>Lesson plan: Step 1; Opening Talk page.</a:t>
+            </a:r>
+          </a:p>
+          <a:p>
+            <a:r>
+              <a:t>Picture: Twemoji graphics by Twitter, Inc. and other contributors (https://github.com/jdecked/twemoji), CC BY 4.0 (https://creativecommons.org/licenses/by/4.0/); resized and combined, with signs and labels (images/CREDITS.md).</a:t>
             </a:r>
           </a:p>
         </p:txBody>
@@ -646,7 +646,7 @@
 </p:notes>
 </file>
 
-<file path=ppt/notesSlides/notesSlide11.xml><?xml version="1.0" encoding="utf-8"?>
+<file path=ppt/notesSlides/notesSlide20.xml><?xml version="1.0" encoding="utf-8"?>
 <p:notes xmlns:a="http://schemas.openxmlformats.org/drawingml/2006/main" xmlns:p="http://schemas.openxmlformats.org/presentationml/2006/main" xmlns:r="http://schemas.openxmlformats.org/officeDocument/2006/relationships">
   <p:cSld>
     <p:spTree>
@@ -691,17 +691,12 @@
           <a:lstStyle/>
           <a:p>
             <a:r>
-              <a:t>Grammar Box 4: review sentences, not a new tense. Each click shows the answer side.</a:t>
-            </a:r>
-          </a:p>
-          <a:p>
-            <a:r>
-              <a:t>Lesson plan: Step 4; Grammar Box 4.</a:t>
-            </a:r>
-          </a:p>
-          <a:p>
-            <a:r>
-              <a:t>Picture: Twemoji graphics by Twitter, Inc. and other contributors (https://github.com/jdecked/twemoji), CC BY 4.0 (https://creativecommons.org/licenses/by/4.0/); resized and combined, with signs and labels (images/CREDITS.md).</a:t>
+              <a:t>Read each goal slowly. Learners repeat.</a:t>
+            </a:r>
+          </a:p>
+          <a:p>
+            <a:r>
+              <a:t>Lesson plan: At a glance: Objectives.</a:t>
             </a:r>
           </a:p>
         </p:txBody>
@@ -726,7 +721,7 @@
 </p:notes>
 </file>
 
-<file path=ppt/notesSlides/notesSlide12.xml><?xml version="1.0" encoding="utf-8"?>
+<file path=ppt/notesSlides/notesSlide26.xml><?xml version="1.0" encoding="utf-8"?>
 <p:notes xmlns:a="http://schemas.openxmlformats.org/drawingml/2006/main" xmlns:p="http://schemas.openxmlformats.org/presentationml/2006/main" xmlns:r="http://schemas.openxmlformats.org/officeDocument/2006/relationships">
   <p:cSld>
     <p:spTree>
@@ -771,12 +766,17 @@
           <a:lstStyle/>
           <a:p>
             <a:r>
-              <a:t>Grammar Box 3: conclusion. Each click shows the answer side.</a:t>
-            </a:r>
-          </a:p>
-          <a:p>
-            <a:r>
-              <a:t>Lesson plan: Step 4; Grammar Box 3.</a:t>
+              <a:t>Welcome learners as they arrive.</a:t>
+            </a:r>
+          </a:p>
+          <a:p>
+            <a:r>
+              <a:t>Read the three lines under Today you will.</a:t>
+            </a:r>
+          </a:p>
+          <a:p>
+            <a:r>
+              <a:t>Lesson plan: Topic; At a glance: Objectives.</a:t>
             </a:r>
           </a:p>
           <a:p>
@@ -806,7 +806,7 @@
 </p:notes>
 </file>
 
-<file path=ppt/notesSlides/notesSlide13.xml><?xml version="1.0" encoding="utf-8"?>
+<file path=ppt/notesSlides/notesSlide31.xml><?xml version="1.0" encoding="utf-8"?>
 <p:notes xmlns:a="http://schemas.openxmlformats.org/drawingml/2006/main" xmlns:p="http://schemas.openxmlformats.org/presentationml/2006/main" xmlns:r="http://schemas.openxmlformats.org/officeDocument/2006/relationships">
   <p:cSld>
     <p:spTree>
@@ -851,17 +851,22 @@
           <a:lstStyle/>
           <a:p>
             <a:r>
-              <a:t>Grammar Box 2: two examples. Each click shows the answer side.</a:t>
-            </a:r>
-          </a:p>
-          <a:p>
-            <a:r>
-              <a:t>Lesson plan: Step 4; Grammar Box 2.</a:t>
-            </a:r>
-          </a:p>
-          <a:p>
-            <a:r>
-              <a:t>Picture: Twemoji graphics by Twitter, Inc. and other contributors (https://github.com/jdecked/twemoji), CC BY 4.0 (https://creativecommons.org/licenses/by/4.0/); resized and combined, with signs and labels (images/CREDITS.md).</a:t>
+              <a:t>Step 2 · 6:06–6:12 · New Words.</a:t>
+            </a:r>
+          </a:p>
+          <a:p>
+            <a:r>
+              <a:t>Point to each picture. Learners repeat. ★ = most important.</a:t>
+            </a:r>
+          </a:p>
+          <a:p>
+            <a:r>
+              <a:t>Lesson plan: Step 2; New Words page.</a:t>
+            </a:r>
+          </a:p>
+          <a:p>
+            <a:r>
+              <a:t>Pictures: Twemoji graphics by Twitter, Inc. and other contributors (https://github.com/jdecked/twemoji), CC BY 4.0 (https://creativecommons.org/licenses/by/4.0/); resized and combined, with signs and labels (images/CREDITS.md).</a:t>
             </a:r>
           </a:p>
         </p:txBody>
@@ -886,7 +891,7 @@
 </p:notes>
 </file>
 
-<file path=ppt/notesSlides/notesSlide15.xml><?xml version="1.0" encoding="utf-8"?>
+<file path=ppt/notesSlides/notesSlide32.xml><?xml version="1.0" encoding="utf-8"?>
 <p:notes xmlns:a="http://schemas.openxmlformats.org/drawingml/2006/main" xmlns:p="http://schemas.openxmlformats.org/presentationml/2006/main" xmlns:r="http://schemas.openxmlformats.org/officeDocument/2006/relationships">
   <p:cSld>
     <p:spTree>
@@ -931,17 +936,17 @@
           <a:lstStyle/>
           <a:p>
             <a:r>
-              <a:t>Grammar Box 1: introduction. Each click shows the answer side.</a:t>
-            </a:r>
-          </a:p>
-          <a:p>
-            <a:r>
-              <a:t>Lesson plan: Step 4; Grammar Box 1.</a:t>
-            </a:r>
-          </a:p>
-          <a:p>
-            <a:r>
-              <a:t>Picture: Twemoji graphics by Twitter, Inc. and other contributors (https://github.com/jdecked/twemoji), CC BY 4.0 (https://creativecommons.org/licenses/by/4.0/); resized and combined, with signs and labels (images/CREDITS.md).</a:t>
+              <a:t>A points to a picture. B names it and uses it in one sentence. Then switch.</a:t>
+            </a:r>
+          </a:p>
+          <a:p>
+            <a:r>
+              <a:t>Lesson plan: Step 2; New Words page; Partner game.</a:t>
+            </a:r>
+          </a:p>
+          <a:p>
+            <a:r>
+              <a:t>Pictures: Twemoji graphics by Twitter, Inc. and other contributors (https://github.com/jdecked/twemoji), CC BY 4.0 (https://creativecommons.org/licenses/by/4.0/); resized and combined, with signs and labels (images/CREDITS.md).</a:t>
             </a:r>
           </a:p>
         </p:txBody>
@@ -966,7 +971,7 @@
 </p:notes>
 </file>
 
-<file path=ppt/notesSlides/notesSlide16.xml><?xml version="1.0" encoding="utf-8"?>
+<file path=ppt/notesSlides/notesSlide33.xml><?xml version="1.0" encoding="utf-8"?>
 <p:notes xmlns:a="http://schemas.openxmlformats.org/drawingml/2006/main" xmlns:p="http://schemas.openxmlformats.org/presentationml/2006/main" xmlns:r="http://schemas.openxmlformats.org/officeDocument/2006/relationships">
   <p:cSld>
     <p:spTree>
@@ -1011,12 +1016,32 @@
           <a:lstStyle/>
           <a:p>
             <a:r>
-              <a:t>gonna and wanna are short forms. This listening uses the full forms. Say each line two times.</a:t>
-            </a:r>
-          </a:p>
-          <a:p>
-            <a:r>
-              <a:t>Lesson plan: Step 3: Hear it, say it.</a:t>
+              <a:t>The answers are hidden. Ask, then click.</a:t>
+            </a:r>
+          </a:p>
+          <a:p>
+            <a:r>
+              <a:t>1. Yes.</a:t>
+            </a:r>
+          </a:p>
+          <a:p>
+            <a:r>
+              <a:t>2. Yes.</a:t>
+            </a:r>
+          </a:p>
+          <a:p>
+            <a:r>
+              <a:t>3. No.</a:t>
+            </a:r>
+          </a:p>
+          <a:p>
+            <a:r>
+              <a:t>Lesson plan: Step 2: Check the Meaning.</a:t>
+            </a:r>
+          </a:p>
+          <a:p>
+            <a:r>
+              <a:t>Pictures: Twemoji graphics by Twitter, Inc. and other contributors (https://github.com/jdecked/twemoji), CC BY 4.0 (https://creativecommons.org/licenses/by/4.0/); resized and combined, with signs and labels (images/CREDITS.md).</a:t>
             </a:r>
           </a:p>
         </p:txBody>
@@ -1041,7 +1066,7 @@
 </p:notes>
 </file>
 
-<file path=ppt/notesSlides/notesSlide17.xml><?xml version="1.0" encoding="utf-8"?>
+<file path=ppt/notesSlides/notesSlide34.xml><?xml version="1.0" encoding="utf-8"?>
 <p:notes xmlns:a="http://schemas.openxmlformats.org/drawingml/2006/main" xmlns:p="http://schemas.openxmlformats.org/presentationml/2006/main" xmlns:r="http://schemas.openxmlformats.org/officeDocument/2006/relationships">
   <p:cSld>
     <p:spTree>
@@ -1086,12 +1111,27 @@
           <a:lstStyle/>
           <a:p>
             <a:r>
-              <a:t>Click to show each answer: 1 Introduction • 2 Example 1 • 3 Example 2 • 4 Conclusion</a:t>
-            </a:r>
-          </a:p>
-          <a:p>
-            <a:r>
-              <a:t>Lesson plan: Step 3; Listening Task C; Answer key.</a:t>
+              <a:t>Step 3 · 6:12–6:32 · Listening. Play 1 is Task A. Play 2 is Tasks B and C. A third play is fine.</a:t>
+            </a:r>
+          </a:p>
+          <a:p>
+            <a:r>
+              <a:t>Imani, a former learner, gives a short talk at a practice night: what she has been learning, one hard moment, one person who helped, and her next step.</a:t>
+            </a:r>
+          </a:p>
+          <a:p>
+            <a:r>
+              <a:t>The script says going to and want to. Learners only need to recognize gonna and wanna.</a:t>
+            </a:r>
+          </a:p>
+          <a:p>
+            <a:r>
+              <a:t>Lesson plan: Step 3; Listening page.</a:t>
+            </a:r>
+          </a:p>
+          <a:p>
+            <a:r>
+              <a:t>Picture: Twemoji graphics by Twitter, Inc. and other contributors (https://github.com/jdecked/twemoji), CC BY 4.0 (https://creativecommons.org/licenses/by/4.0/); resized and combined, with signs and labels (images/CREDITS.md).</a:t>
             </a:r>
           </a:p>
         </p:txBody>
@@ -1116,7 +1156,7 @@
 </p:notes>
 </file>
 
-<file path=ppt/notesSlides/notesSlide19.xml><?xml version="1.0" encoding="utf-8"?>
+<file path=ppt/notesSlides/notesSlide35.xml><?xml version="1.0" encoding="utf-8"?>
 <p:notes xmlns:a="http://schemas.openxmlformats.org/drawingml/2006/main" xmlns:p="http://schemas.openxmlformats.org/presentationml/2006/main" xmlns:r="http://schemas.openxmlformats.org/officeDocument/2006/relationships">
   <p:cSld>
     <p:spTree>
@@ -1161,12 +1201,12 @@
           <a:lstStyle/>
           <a:p>
             <a:r>
-              <a:t>Click to circle each answer: 1 introduction • 2 example • 3 example • 4 conclusion • 5 a stopwatch • 6 finishing</a:t>
-            </a:r>
-          </a:p>
-          <a:p>
-            <a:r>
-              <a:t>Lesson plan: Step 3; Listening Task B; Answer key.</a:t>
+              <a:t>Click to circle b.</a:t>
+            </a:r>
+          </a:p>
+          <a:p>
+            <a:r>
+              <a:t>Lesson plan: Step 3; Listening Task A; Answer key.</a:t>
             </a:r>
           </a:p>
         </p:txBody>
@@ -1191,7 +1231,7 @@
 </p:notes>
 </file>
 
-<file path=ppt/notesSlides/notesSlide2.xml><?xml version="1.0" encoding="utf-8"?>
+<file path=ppt/notesSlides/notesSlide36.xml><?xml version="1.0" encoding="utf-8"?>
 <p:notes xmlns:a="http://schemas.openxmlformats.org/drawingml/2006/main" xmlns:p="http://schemas.openxmlformats.org/presentationml/2006/main" xmlns:r="http://schemas.openxmlformats.org/officeDocument/2006/relationships">
   <p:cSld>
     <p:spTree>
@@ -1236,22 +1276,12 @@
           <a:lstStyle/>
           <a:p>
             <a:r>
-              <a:t>Step 7 · 7:25–7:30 · Exit ticket and homework. Never skip the exit ticket.</a:t>
-            </a:r>
-          </a:p>
-          <a:p>
-            <a:r>
-              <a:t>Write your introduction and your conclusion only.</a:t>
-            </a:r>
-          </a:p>
-          <a:p>
-            <a:r>
-              <a:t>Lesson plan: Step 7; Exit Ticket page; Homework page.</a:t>
-            </a:r>
-          </a:p>
-          <a:p>
-            <a:r>
-              <a:t>Picture: Twemoji graphics by Twitter, Inc. and other contributors (https://github.com/jdecked/twemoji), CC BY 4.0 (https://creativecommons.org/licenses/by/4.0/); resized and combined, with signs and labels (images/CREDITS.md).</a:t>
+              <a:t>Click to circle each answer: 1 introduction • 2 example • 3 example • 4 conclusion • 5 a stopwatch • 6 finishing</a:t>
+            </a:r>
+          </a:p>
+          <a:p>
+            <a:r>
+              <a:t>Lesson plan: Step 3; Listening Task B; Answer key.</a:t>
             </a:r>
           </a:p>
         </p:txBody>
@@ -1276,7 +1306,7 @@
 </p:notes>
 </file>
 
-<file path=ppt/notesSlides/notesSlide21.xml><?xml version="1.0" encoding="utf-8"?>
+<file path=ppt/notesSlides/notesSlide37.xml><?xml version="1.0" encoding="utf-8"?>
 <p:notes xmlns:a="http://schemas.openxmlformats.org/drawingml/2006/main" xmlns:p="http://schemas.openxmlformats.org/presentationml/2006/main" xmlns:r="http://schemas.openxmlformats.org/officeDocument/2006/relationships">
   <p:cSld>
     <p:spTree>
@@ -1321,12 +1351,12 @@
           <a:lstStyle/>
           <a:p>
             <a:r>
-              <a:t>Click to circle b.</a:t>
-            </a:r>
-          </a:p>
-          <a:p>
-            <a:r>
-              <a:t>Lesson plan: Step 3; Listening Task A; Answer key.</a:t>
+              <a:t>Click to show each answer: 1 Introduction • 2 Example 1 • 3 Example 2 • 4 Conclusion</a:t>
+            </a:r>
+          </a:p>
+          <a:p>
+            <a:r>
+              <a:t>Lesson plan: Step 3; Listening Task C; Answer key.</a:t>
             </a:r>
           </a:p>
         </p:txBody>
@@ -1351,7 +1381,7 @@
 </p:notes>
 </file>
 
-<file path=ppt/notesSlides/notesSlide22.xml><?xml version="1.0" encoding="utf-8"?>
+<file path=ppt/notesSlides/notesSlide38.xml><?xml version="1.0" encoding="utf-8"?>
 <p:notes xmlns:a="http://schemas.openxmlformats.org/drawingml/2006/main" xmlns:p="http://schemas.openxmlformats.org/presentationml/2006/main" xmlns:r="http://schemas.openxmlformats.org/officeDocument/2006/relationships">
   <p:cSld>
     <p:spTree>
@@ -1396,122 +1426,12 @@
           <a:lstStyle/>
           <a:p>
             <a:r>
-              <a:t>Step 3 · 6:12–6:32 · Listening. Play 1 is Task A. Play 2 is Tasks B and C. A third play is fine.</a:t>
-            </a:r>
-          </a:p>
-          <a:p>
-            <a:r>
-              <a:t>Imani, a former learner, gives a short talk at a practice night: what she has been learning, one hard moment, one person who helped, and her next step.</a:t>
-            </a:r>
-          </a:p>
-          <a:p>
-            <a:r>
-              <a:t>The script says going to and want to. Learners only need to recognize gonna and wanna.</a:t>
-            </a:r>
-          </a:p>
-          <a:p>
-            <a:r>
-              <a:t>Lesson plan: Step 3; Listening page.</a:t>
-            </a:r>
-          </a:p>
-          <a:p>
-            <a:r>
-              <a:t>Picture: Twemoji graphics by Twitter, Inc. and other contributors (https://github.com/jdecked/twemoji), CC BY 4.0 (https://creativecommons.org/licenses/by/4.0/); resized and combined, with signs and labels (images/CREDITS.md).</a:t>
-            </a:r>
-          </a:p>
-          <a:p>
-            <a:r>
-              <a:t>Listening script (the audio is coming soon; until then, read it aloud with a volunteer at a normal, friendly speed):</a:t>
-            </a:r>
-          </a:p>
-          <a:p>
-            <a:r>
-              <a:t>Narrator: Lesson thirteen. Imani, a former learner, gives a short talk at a practice night at the community center. Then Mr. Gordon asks one question.</a:t>
-            </a:r>
-          </a:p>
-          <a:p>
-            <a:r>
-              <a:t>Imani: Good evening. My point is simple. I've been learning to speak up at work, and a mentor helped me.</a:t>
-            </a:r>
-          </a:p>
-          <a:p>
-            <a:r>
-              <a:t>Imani: That is my introduction. I want to give two examples.</a:t>
-            </a:r>
-          </a:p>
-          <a:p>
-            <a:r>
-              <a:t>Imani: Example one. By the time I finished my first month, I had learned to pause and look up from my notecard.</a:t>
-            </a:r>
-          </a:p>
-          <a:p>
-            <a:r>
-              <a:t>Imani: The hard moment was a team meeting. I wish I had looked up sooner, so next time I will make eye contact.</a:t>
-            </a:r>
-          </a:p>
-          <a:p>
-            <a:r>
-              <a:t>Imani: Example two. My mentor at the community center listened and asked one question.</a:t>
-            </a:r>
-          </a:p>
-          <a:p>
-            <a:r>
-              <a:t>Imani: That question helped me find my point. The achievement was small, and it was mine.</a:t>
-            </a:r>
-          </a:p>
-          <a:p>
-            <a:r>
-              <a:t>Imani: I'm going to practice with a stopwatch for two minutes. The outline is on my notecard.</a:t>
-            </a:r>
-          </a:p>
-          <a:p>
-            <a:r>
-              <a:t>Imani: This is my conclusion. I can speak from notes. My next step is one short talk a week at work.</a:t>
-            </a:r>
-          </a:p>
-          <a:p>
-            <a:r>
-              <a:t>Mr. Gordon: Thank you, Imani. Which example do you want to keep?</a:t>
-            </a:r>
-          </a:p>
-          <a:p>
-            <a:r>
-              <a:t>Imani: I want to keep the mentor example. I'm going to say it again, more slowly.</a:t>
-            </a:r>
-          </a:p>
-          <a:p>
-            <a:r>
-              <a:t>Mr. Gordon: Good. A pause between the parts helps. Applause is for finishing, not for the longest story.</a:t>
-            </a:r>
-          </a:p>
-          <a:p>
-            <a:r>
-              <a:t>Imani: I am not going to memorize the talk. Eye contact means I look up from the card.</a:t>
-            </a:r>
-          </a:p>
-          <a:p>
-            <a:r>
-              <a:t>Mr. Gordon: What is your next step, in one sentence?</a:t>
-            </a:r>
-          </a:p>
-          <a:p>
-            <a:r>
-              <a:t>Imani: I'm going to practice one talk a week. I want to keep the introduction short.</a:t>
-            </a:r>
-          </a:p>
-          <a:p>
-            <a:r>
-              <a:t>Mr. Gordon: The conclusion should repeat the point, not start a new story.</a:t>
-            </a:r>
-          </a:p>
-          <a:p>
-            <a:r>
-              <a:t>Imani: An achievement can be small. My class, my job, or a person who helped me is enough.</a:t>
-            </a:r>
-          </a:p>
-          <a:p>
-            <a:r>
-              <a:t>Narrator: That's the end of the listening.</a:t>
+              <a:t>gonna and wanna are short forms. This listening uses the full forms. Say each line two times.</a:t>
+            </a:r>
+          </a:p>
+          <a:p>
+            <a:r>
+              <a:t>Lesson plan: Step 3: Hear it, say it.</a:t>
             </a:r>
           </a:p>
         </p:txBody>
@@ -1536,7 +1456,7 @@
 </p:notes>
 </file>
 
-<file path=ppt/notesSlides/notesSlide23.xml><?xml version="1.0" encoding="utf-8"?>
+<file path=ppt/notesSlides/notesSlide39.xml><?xml version="1.0" encoding="utf-8"?>
 <p:notes xmlns:a="http://schemas.openxmlformats.org/drawingml/2006/main" xmlns:p="http://schemas.openxmlformats.org/presentationml/2006/main" xmlns:r="http://schemas.openxmlformats.org/officeDocument/2006/relationships">
   <p:cSld>
     <p:spTree>
@@ -1581,32 +1501,17 @@
           <a:lstStyle/>
           <a:p>
             <a:r>
-              <a:t>The answers are hidden. Ask, then click.</a:t>
-            </a:r>
-          </a:p>
-          <a:p>
-            <a:r>
-              <a:t>1. Yes.</a:t>
-            </a:r>
-          </a:p>
-          <a:p>
-            <a:r>
-              <a:t>2. Yes.</a:t>
-            </a:r>
-          </a:p>
-          <a:p>
-            <a:r>
-              <a:t>3. No.</a:t>
-            </a:r>
-          </a:p>
-          <a:p>
-            <a:r>
-              <a:t>Lesson plan: Step 2: Check the Meaning.</a:t>
-            </a:r>
-          </a:p>
-          <a:p>
-            <a:r>
-              <a:t>Pictures: Twemoji graphics by Twitter, Inc. and other contributors (https://github.com/jdecked/twemoji), CC BY 4.0 (https://creativecommons.org/licenses/by/4.0/); resized and combined, with signs and labels (images/CREDITS.md).</a:t>
+              <a:t>Grammar Box 1: introduction. Each click shows the answer side.</a:t>
+            </a:r>
+          </a:p>
+          <a:p>
+            <a:r>
+              <a:t>Lesson plan: Step 4; Grammar Box 1.</a:t>
+            </a:r>
+          </a:p>
+          <a:p>
+            <a:r>
+              <a:t>Picture: Twemoji graphics by Twitter, Inc. and other contributors (https://github.com/jdecked/twemoji), CC BY 4.0 (https://creativecommons.org/licenses/by/4.0/); resized and combined, with signs and labels (images/CREDITS.md).</a:t>
             </a:r>
           </a:p>
         </p:txBody>
@@ -1631,7 +1536,7 @@
 </p:notes>
 </file>
 
-<file path=ppt/notesSlides/notesSlide24.xml><?xml version="1.0" encoding="utf-8"?>
+<file path=ppt/notesSlides/notesSlide40.xml><?xml version="1.0" encoding="utf-8"?>
 <p:notes xmlns:a="http://schemas.openxmlformats.org/drawingml/2006/main" xmlns:p="http://schemas.openxmlformats.org/presentationml/2006/main" xmlns:r="http://schemas.openxmlformats.org/officeDocument/2006/relationships">
   <p:cSld>
     <p:spTree>
@@ -1676,17 +1581,17 @@
           <a:lstStyle/>
           <a:p>
             <a:r>
-              <a:t>A points to a picture. B names it and uses it in one sentence. Then switch.</a:t>
-            </a:r>
-          </a:p>
-          <a:p>
-            <a:r>
-              <a:t>Lesson plan: Step 2; New Words page; Partner game.</a:t>
-            </a:r>
-          </a:p>
-          <a:p>
-            <a:r>
-              <a:t>Pictures: Twemoji graphics by Twitter, Inc. and other contributors (https://github.com/jdecked/twemoji), CC BY 4.0 (https://creativecommons.org/licenses/by/4.0/); resized and combined, with signs and labels (images/CREDITS.md).</a:t>
+              <a:t>Grammar Box 2: two examples. Each click shows the answer side.</a:t>
+            </a:r>
+          </a:p>
+          <a:p>
+            <a:r>
+              <a:t>Lesson plan: Step 4; Grammar Box 2.</a:t>
+            </a:r>
+          </a:p>
+          <a:p>
+            <a:r>
+              <a:t>Picture: Twemoji graphics by Twitter, Inc. and other contributors (https://github.com/jdecked/twemoji), CC BY 4.0 (https://creativecommons.org/licenses/by/4.0/); resized and combined, with signs and labels (images/CREDITS.md).</a:t>
             </a:r>
           </a:p>
         </p:txBody>
@@ -1711,7 +1616,7 @@
 </p:notes>
 </file>
 
-<file path=ppt/notesSlides/notesSlide25.xml><?xml version="1.0" encoding="utf-8"?>
+<file path=ppt/notesSlides/notesSlide41.xml><?xml version="1.0" encoding="utf-8"?>
 <p:notes xmlns:a="http://schemas.openxmlformats.org/drawingml/2006/main" xmlns:p="http://schemas.openxmlformats.org/presentationml/2006/main" xmlns:r="http://schemas.openxmlformats.org/officeDocument/2006/relationships">
   <p:cSld>
     <p:spTree>
@@ -1756,22 +1661,17 @@
           <a:lstStyle/>
           <a:p>
             <a:r>
-              <a:t>Step 2 · 6:06–6:12 · New Words.</a:t>
-            </a:r>
-          </a:p>
-          <a:p>
-            <a:r>
-              <a:t>Point to each picture. Learners repeat. ★ = most important.</a:t>
-            </a:r>
-          </a:p>
-          <a:p>
-            <a:r>
-              <a:t>Lesson plan: Step 2; New Words page.</a:t>
-            </a:r>
-          </a:p>
-          <a:p>
-            <a:r>
-              <a:t>Pictures: Twemoji graphics by Twitter, Inc. and other contributors (https://github.com/jdecked/twemoji), CC BY 4.0 (https://creativecommons.org/licenses/by/4.0/); resized and combined, with signs and labels (images/CREDITS.md).</a:t>
+              <a:t>Grammar Box 3: conclusion. Each click shows the answer side.</a:t>
+            </a:r>
+          </a:p>
+          <a:p>
+            <a:r>
+              <a:t>Lesson plan: Step 4; Grammar Box 3.</a:t>
+            </a:r>
+          </a:p>
+          <a:p>
+            <a:r>
+              <a:t>Picture: Twemoji graphics by Twitter, Inc. and other contributors (https://github.com/jdecked/twemoji), CC BY 4.0 (https://creativecommons.org/licenses/by/4.0/); resized and combined, with signs and labels (images/CREDITS.md).</a:t>
             </a:r>
           </a:p>
         </p:txBody>
@@ -1796,7 +1696,7 @@
 </p:notes>
 </file>
 
-<file path=ppt/notesSlides/notesSlide27.xml><?xml version="1.0" encoding="utf-8"?>
+<file path=ppt/notesSlides/notesSlide42.xml><?xml version="1.0" encoding="utf-8"?>
 <p:notes xmlns:a="http://schemas.openxmlformats.org/drawingml/2006/main" xmlns:p="http://schemas.openxmlformats.org/presentationml/2006/main" xmlns:r="http://schemas.openxmlformats.org/officeDocument/2006/relationships">
   <p:cSld>
     <p:spTree>
@@ -1841,17 +1741,12 @@
           <a:lstStyle/>
           <a:p>
             <a:r>
-              <a:t>Welcome learners as they arrive.</a:t>
-            </a:r>
-          </a:p>
-          <a:p>
-            <a:r>
-              <a:t>Read the three lines under Today you will.</a:t>
-            </a:r>
-          </a:p>
-          <a:p>
-            <a:r>
-              <a:t>Lesson plan: Topic; At a glance: Objectives.</a:t>
+              <a:t>Grammar Box 4: review sentences, not a new tense. Each click shows the answer side.</a:t>
+            </a:r>
+          </a:p>
+          <a:p>
+            <a:r>
+              <a:t>Lesson plan: Step 4; Grammar Box 4.</a:t>
             </a:r>
           </a:p>
           <a:p>
@@ -1881,7 +1776,7 @@
 </p:notes>
 </file>
 
-<file path=ppt/notesSlides/notesSlide28.xml><?xml version="1.0" encoding="utf-8"?>
+<file path=ppt/notesSlides/notesSlide43.xml><?xml version="1.0" encoding="utf-8"?>
 <p:notes xmlns:a="http://schemas.openxmlformats.org/drawingml/2006/main" xmlns:p="http://schemas.openxmlformats.org/presentationml/2006/main" xmlns:r="http://schemas.openxmlformats.org/officeDocument/2006/relationships">
   <p:cSld>
     <p:spTree>
@@ -1926,12 +1821,12 @@
           <a:lstStyle/>
           <a:p>
             <a:r>
-              <a:t>Read each goal slowly. Learners repeat.</a:t>
-            </a:r>
-          </a:p>
-          <a:p>
-            <a:r>
-              <a:t>Lesson plan: At a glance: Objectives.</a:t>
+              <a:t>Click to show each answer: 1 Introduction • 2 Example • 3 Example • 4 Conclusion • 5 Conclusion • 6 Example</a:t>
+            </a:r>
+          </a:p>
+          <a:p>
+            <a:r>
+              <a:t>Lesson plan: Step 4; Grammar Practice A; Answer key.</a:t>
             </a:r>
           </a:p>
         </p:txBody>
@@ -1956,7 +1851,7 @@
 </p:notes>
 </file>
 
-<file path=ppt/notesSlides/notesSlide29.xml><?xml version="1.0" encoding="utf-8"?>
+<file path=ppt/notesSlides/notesSlide44.xml><?xml version="1.0" encoding="utf-8"?>
 <p:notes xmlns:a="http://schemas.openxmlformats.org/drawingml/2006/main" xmlns:p="http://schemas.openxmlformats.org/presentationml/2006/main" xmlns:r="http://schemas.openxmlformats.org/officeDocument/2006/relationships">
   <p:cSld>
     <p:spTree>
@@ -2001,22 +1896,12 @@
           <a:lstStyle/>
           <a:p>
             <a:r>
-              <a:t>Step 1 · 6:00–6:06 · Opening Talk.</a:t>
-            </a:r>
-          </a:p>
-          <a:p>
-            <a:r>
-              <a:t>Work with a partner.</a:t>
-            </a:r>
-          </a:p>
-          <a:p>
-            <a:r>
-              <a:t>Lesson plan: Step 1; Opening Talk page.</a:t>
-            </a:r>
-          </a:p>
-          <a:p>
-            <a:r>
-              <a:t>Picture: Twemoji graphics by Twitter, Inc. and other contributors (https://github.com/jdecked/twemoji), CC BY 4.0 (https://creativecommons.org/licenses/by/4.0/); resized and combined, with signs and labels (images/CREDITS.md).</a:t>
+              <a:t>Click to circle each answer: 1 names the point • 2 has a detail • 3 repeats the point • 4 I'm going to • 5 had learned • 6 learning</a:t>
+            </a:r>
+          </a:p>
+          <a:p>
+            <a:r>
+              <a:t>Lesson plan: Step 4; Grammar Practice B; Answer key.</a:t>
             </a:r>
           </a:p>
         </p:txBody>
@@ -2041,7 +1926,7 @@
 </p:notes>
 </file>
 
-<file path=ppt/notesSlides/notesSlide3.xml><?xml version="1.0" encoding="utf-8"?>
+<file path=ppt/notesSlides/notesSlide45.xml><?xml version="1.0" encoding="utf-8"?>
 <p:notes xmlns:a="http://schemas.openxmlformats.org/drawingml/2006/main" xmlns:p="http://schemas.openxmlformats.org/presentationml/2006/main" xmlns:r="http://schemas.openxmlformats.org/officeDocument/2006/relationships">
   <p:cSld>
     <p:spTree>
@@ -2086,17 +1971,17 @@
           <a:lstStyle/>
           <a:p>
             <a:r>
-              <a:t>Step 6 · 7:18–7:25 · Read &amp; Write.</a:t>
-            </a:r>
-          </a:p>
-          <a:p>
-            <a:r>
-              <a:t>Click to show each answer: 1 She has been learning to speak up at work • 2 She did not look up • 3 Her mentor • 4 One short talk a week • 5 It repeats the point and adds a next step</a:t>
-            </a:r>
-          </a:p>
-          <a:p>
-            <a:r>
-              <a:t>Lesson plan: Step 6; Read &amp; Write page; Answer key.</a:t>
+              <a:t>Read Don't say, then Say. Learners try first. Then click.</a:t>
+            </a:r>
+          </a:p>
+          <a:p>
+            <a:r>
+              <a:t>Lesson plan: Grammar: Common mistakes.</a:t>
+            </a:r>
+          </a:p>
+          <a:p>
+            <a:r>
+              <a:t>Picture: Twemoji graphics by Twitter, Inc. and other contributors (https://github.com/jdecked/twemoji), CC BY 4.0 (https://creativecommons.org/licenses/by/4.0/); resized and combined, with signs and labels (images/CREDITS.md).</a:t>
             </a:r>
           </a:p>
         </p:txBody>
@@ -2121,7 +2006,7 @@
 </p:notes>
 </file>
 
-<file path=ppt/notesSlides/notesSlide30.xml><?xml version="1.0" encoding="utf-8"?>
+<file path=ppt/notesSlides/notesSlide46.xml><?xml version="1.0" encoding="utf-8"?>
 <p:notes xmlns:a="http://schemas.openxmlformats.org/drawingml/2006/main" xmlns:p="http://schemas.openxmlformats.org/presentationml/2006/main" xmlns:r="http://schemas.openxmlformats.org/officeDocument/2006/relationships">
   <p:cSld>
     <p:spTree>
@@ -2166,17 +2051,22 @@
           <a:lstStyle/>
           <a:p>
             <a:r>
-              <a:t>Each click shows the next card.</a:t>
-            </a:r>
-          </a:p>
-          <a:p>
-            <a:r>
-              <a:t>A asks. B answers. Then switch.</a:t>
-            </a:r>
-          </a:p>
-          <a:p>
-            <a:r>
-              <a:t>Lesson plan: Step 1; Opening Talk page.</a:t>
+              <a:t>A says "introduction," "example," or "conclusion." B says what that part must do. Then switch. ---</a:t>
+            </a:r>
+          </a:p>
+          <a:p>
+            <a:r>
+              <a:t>Break · 6:45–7:00.</a:t>
+            </a:r>
+          </a:p>
+          <a:p>
+            <a:r>
+              <a:t>Lesson plan: Step 4: Pair check.</a:t>
+            </a:r>
+          </a:p>
+          <a:p>
+            <a:r>
+              <a:t>Picture: Twemoji graphics by Twitter, Inc. and other contributors (https://github.com/jdecked/twemoji), CC BY 4.0 (https://creativecommons.org/licenses/by/4.0/); resized and combined, with signs and labels (images/CREDITS.md).</a:t>
             </a:r>
           </a:p>
         </p:txBody>
@@ -2201,7 +2091,7 @@
 </p:notes>
 </file>
 
-<file path=ppt/notesSlides/notesSlide4.xml><?xml version="1.0" encoding="utf-8"?>
+<file path=ppt/notesSlides/notesSlide47.xml><?xml version="1.0" encoding="utf-8"?>
 <p:notes xmlns:a="http://schemas.openxmlformats.org/drawingml/2006/main" xmlns:p="http://schemas.openxmlformats.org/presentationml/2006/main" xmlns:r="http://schemas.openxmlformats.org/officeDocument/2006/relationships">
   <p:cSld>
     <p:spTree>
@@ -2246,7 +2136,7 @@
           <a:lstStyle/>
           <a:p>
             <a:r>
-              <a:t>Round 2.</a:t>
+              <a:t>Round 1.</a:t>
             </a:r>
           </a:p>
           <a:p>
@@ -2281,7 +2171,7 @@
 </p:notes>
 </file>
 
-<file path=ppt/notesSlides/notesSlide5.xml><?xml version="1.0" encoding="utf-8"?>
+<file path=ppt/notesSlides/notesSlide48.xml><?xml version="1.0" encoding="utf-8"?>
 <p:notes xmlns:a="http://schemas.openxmlformats.org/drawingml/2006/main" xmlns:p="http://schemas.openxmlformats.org/presentationml/2006/main" xmlns:r="http://schemas.openxmlformats.org/officeDocument/2006/relationships">
   <p:cSld>
     <p:spTree>
@@ -2326,7 +2216,7 @@
           <a:lstStyle/>
           <a:p>
             <a:r>
-              <a:t>Round 1.</a:t>
+              <a:t>Round 2.</a:t>
             </a:r>
           </a:p>
           <a:p>
@@ -2361,7 +2251,7 @@
 </p:notes>
 </file>
 
-<file path=ppt/notesSlides/notesSlide51.xml><?xml version="1.0" encoding="utf-8"?>
+<file path=ppt/notesSlides/notesSlide49.xml><?xml version="1.0" encoding="utf-8"?>
 <p:notes xmlns:a="http://schemas.openxmlformats.org/drawingml/2006/main" xmlns:p="http://schemas.openxmlformats.org/presentationml/2006/main" xmlns:r="http://schemas.openxmlformats.org/officeDocument/2006/relationships">
   <p:cSld>
     <p:spTree>
@@ -2406,22 +2296,17 @@
           <a:lstStyle/>
           <a:p>
             <a:r>
-              <a:t>Read the three Now you can lines.</a:t>
-            </a:r>
-          </a:p>
-          <a:p>
-            <a:r>
-              <a:t>Homework is about 20–25 minutes. Bring it next week.</a:t>
-            </a:r>
-          </a:p>
-          <a:p>
-            <a:r>
-              <a:t>Lesson plan: At a glance: Objectives; Step 7.</a:t>
-            </a:r>
-          </a:p>
-          <a:p>
-            <a:r>
-              <a:t>Picture: Twemoji graphics by Twitter, Inc. and other contributors (https://github.com/jdecked/twemoji), CC BY 4.0 (https://creativecommons.org/licenses/by/4.0/); resized and combined, with signs and labels (images/CREDITS.md).</a:t>
+              <a:t>Step 6 · 7:18–7:25 · Read &amp; Write.</a:t>
+            </a:r>
+          </a:p>
+          <a:p>
+            <a:r>
+              <a:t>Click to show each answer: 1 She has been learning to speak up at work • 2 She did not look up • 3 Her mentor • 4 One short talk a week • 5 It repeats the point and adds a next step</a:t>
+            </a:r>
+          </a:p>
+          <a:p>
+            <a:r>
+              <a:t>Lesson plan: Step 6; Read &amp; Write page; Answer key.</a:t>
             </a:r>
           </a:p>
         </p:txBody>
@@ -2446,7 +2331,7 @@
 </p:notes>
 </file>
 
-<file path=ppt/notesSlides/notesSlide6.xml><?xml version="1.0" encoding="utf-8"?>
+<file path=ppt/notesSlides/notesSlide50.xml><?xml version="1.0" encoding="utf-8"?>
 <p:notes xmlns:a="http://schemas.openxmlformats.org/drawingml/2006/main" xmlns:p="http://schemas.openxmlformats.org/presentationml/2006/main" xmlns:r="http://schemas.openxmlformats.org/officeDocument/2006/relationships">
   <p:cSld>
     <p:spTree>
@@ -2491,17 +2376,17 @@
           <a:lstStyle/>
           <a:p>
             <a:r>
-              <a:t>A says "introduction," "example," or "conclusion." B says what that part must do. Then switch. ---</a:t>
-            </a:r>
-          </a:p>
-          <a:p>
-            <a:r>
-              <a:t>Break · 6:45–7:00.</a:t>
-            </a:r>
-          </a:p>
-          <a:p>
-            <a:r>
-              <a:t>Lesson plan: Step 4: Pair check.</a:t>
+              <a:t>Step 7 · 7:25–7:30 · Exit ticket and homework. Never skip the exit ticket.</a:t>
+            </a:r>
+          </a:p>
+          <a:p>
+            <a:r>
+              <a:t>Write your introduction and your conclusion only.</a:t>
+            </a:r>
+          </a:p>
+          <a:p>
+            <a:r>
+              <a:t>Lesson plan: Step 7; Exit Ticket page; Homework page.</a:t>
             </a:r>
           </a:p>
           <a:p>
@@ -2531,7 +2416,7 @@
 </p:notes>
 </file>
 
-<file path=ppt/notesSlides/notesSlide7.xml><?xml version="1.0" encoding="utf-8"?>
+<file path=ppt/notesSlides/notesSlide52.xml><?xml version="1.0" encoding="utf-8"?>
 <p:notes xmlns:a="http://schemas.openxmlformats.org/drawingml/2006/main" xmlns:p="http://schemas.openxmlformats.org/presentationml/2006/main" xmlns:r="http://schemas.openxmlformats.org/officeDocument/2006/relationships">
   <p:cSld>
     <p:spTree>
@@ -2576,17 +2461,27 @@
           <a:lstStyle/>
           <a:p>
             <a:r>
-              <a:t>Read Don't say, then Say. Learners try first. Then click.</a:t>
-            </a:r>
-          </a:p>
-          <a:p>
-            <a:r>
-              <a:t>Lesson plan: Grammar: Common mistakes.</a:t>
-            </a:r>
-          </a:p>
-          <a:p>
-            <a:r>
-              <a:t>Picture: Twemoji graphics by Twitter, Inc. and other contributors (https://github.com/jdecked/twemoji), CC BY 4.0 (https://creativecommons.org/licenses/by/4.0/); resized and combined, with signs and labels (images/CREDITS.md).</a:t>
+              <a:t>Credits. You don't need to read this slide in class.</a:t>
+            </a:r>
+          </a:p>
+          <a:p>
+            <a:r>
+              <a:t>Pictures: Twemoji graphics by Twitter, Inc. and other contributors, CC BY 4.0; the file-by-file list is in images/CREDITS.md.</a:t>
+            </a:r>
+          </a:p>
+          <a:p>
+            <a:r>
+              <a:t>Audio: synthetic voices, computer-generated (Chatterbox TTS cloned from Kokoro-82M reference clips). No recordings of real people. The names and the story are invented.</a:t>
+            </a:r>
+          </a:p>
+          <a:p>
+            <a:r>
+              <a:t>Course materials: © 2026 the authors, licensed under CC BY-NC-SA 4.0 (https://creativecommons.org/licenses/by-nc-sa/4.0/).</a:t>
+            </a:r>
+          </a:p>
+          <a:p>
+            <a:r>
+              <a:t>Lesson plan: Picture Credits. Picture list: images/CREDITS.md.</a:t>
             </a:r>
           </a:p>
         </p:txBody>
@@ -2611,7 +2506,7 @@
 </p:notes>
 </file>
 
-<file path=ppt/notesSlides/notesSlide9.xml><?xml version="1.0" encoding="utf-8"?>
+<file path=ppt/notesSlides/notesSlide8.xml><?xml version="1.0" encoding="utf-8"?>
 <p:notes xmlns:a="http://schemas.openxmlformats.org/drawingml/2006/main" xmlns:p="http://schemas.openxmlformats.org/presentationml/2006/main" xmlns:r="http://schemas.openxmlformats.org/officeDocument/2006/relationships">
   <p:cSld>
     <p:spTree>
@@ -2656,12 +2551,22 @@
           <a:lstStyle/>
           <a:p>
             <a:r>
-              <a:t>Click to circle each answer: 1 names the point • 2 has a detail • 3 repeats the point • 4 I'm going to • 5 had learned • 6 learning</a:t>
-            </a:r>
-          </a:p>
-          <a:p>
-            <a:r>
-              <a:t>Lesson plan: Step 4; Grammar Practice B; Answer key.</a:t>
+              <a:t>Read the three Now you can lines.</a:t>
+            </a:r>
+          </a:p>
+          <a:p>
+            <a:r>
+              <a:t>Homework is about 20–25 minutes. Bring it next week.</a:t>
+            </a:r>
+          </a:p>
+          <a:p>
+            <a:r>
+              <a:t>Lesson plan: At a glance: Objectives; Step 7.</a:t>
+            </a:r>
+          </a:p>
+          <a:p>
+            <a:r>
+              <a:t>Picture: Twemoji graphics by Twitter, Inc. and other contributors (https://github.com/jdecked/twemoji), CC BY 4.0 (https://creativecommons.org/licenses/by/4.0/); resized and combined, with signs and labels (images/CREDITS.md).</a:t>
             </a:r>
           </a:p>
         </p:txBody>
@@ -9150,7 +9055,7 @@
             <a:r>
               <a:rPr lang="en-US" sz="2800" dirty="0" b="1">
                 <a:solidFill>
-                  <a:srgbClr val="1B2236"/>
+                  <a:srgbClr val="5B3FC4"/>
                 </a:solidFill>
                 <a:latin typeface="Lexend Deca" pitchFamily="34" charset="0"/>
                 <a:ea typeface="Lexend Deca" pitchFamily="34" charset="-122"/>
@@ -9197,7 +9102,7 @@
             <a:r>
               <a:rPr lang="en-US" sz="2800" dirty="0" b="1">
                 <a:solidFill>
-                  <a:srgbClr val="1B2236"/>
+                  <a:srgbClr val="5B3FC4"/>
                 </a:solidFill>
                 <a:latin typeface="Lexend Deca" pitchFamily="34" charset="0"/>
                 <a:ea typeface="Lexend Deca" pitchFamily="34" charset="-122"/>
@@ -10299,7 +10204,7 @@
                 <a:ea typeface="Lexend Deca" pitchFamily="34" charset="-122"/>
                 <a:cs typeface="Lexend Deca" pitchFamily="34" charset="-120"/>
               </a:rPr>
-              <a:t>Audio (about 2:20): coming soon.</a:t>
+              <a:t>Audio: about 1:47. It plays once.</a:t>
             </a:r>
             <a:endParaRPr lang="en-US" sz="2200" dirty="0"/>
           </a:p>
@@ -28234,7 +28139,7 @@
                 <a:ea typeface="Lexend Deca" pitchFamily="34" charset="-122"/>
                 <a:cs typeface="Lexend Deca" pitchFamily="34" charset="-120"/>
               </a:rPr>
-              <a:t>Audio (coming soon): synthetic voices made with Chatterbox TTS (MIT License), cloned from short synthetic reference clips made with Kokoro-82M (Apache License 2.0). No recordings of real people. Each file will carry an inaudible Perth watermark marking it as AI-generated. Font: Lexend Deca (OFL 1.1).</a:t>
+              <a:t>Audio: synthetic voices made with Chatterbox TTS (MIT License), cloned from short synthetic reference clips made with Kokoro-82M (Apache License 2.0). No recordings of real people were used. Each file carries an inaudible Perth watermark marking it as AI-generated. Font: Lexend Deca (OFL 1.1).</a:t>
             </a:r>
             <a:endParaRPr lang="en-US" sz="1350" dirty="0" b="0"/>
           </a:p>

</xml_diff>